<commit_message>
Make Day 1 evergreen: replace dated weekly/quarterly stats + chart with timeless framing
</commit_message>
<xml_diff>
--- a/bridges-allies/BridgesAllies_OffPlan_Training_Day1.pptx
+++ b/bridges-allies/BridgesAllies_OffPlan_Training_Day1.pptx
@@ -119,247 +119,6 @@
 </p:presentation>
 </file>
 
-<file path=ppt/charts/chart1.xml><?xml version="1.0" encoding="utf-8"?>
-<c:chartSpace xmlns:c="http://schemas.openxmlformats.org/drawingml/2006/chart" xmlns:a="http://schemas.openxmlformats.org/drawingml/2006/main" xmlns:r="http://schemas.openxmlformats.org/officeDocument/2006/relationships">
-  <c:date1904 val="0"/>
-  <c:roundedCorners val="1"/>
-  <c:chart>
-    <c:autoTitleDeleted val="1"/>
-    <c:plotArea>
-      <c:layout/>
-      <c:barChart>
-        <c:barDir val="col"/>
-        <c:grouping val="clustered"/>
-        <c:varyColors val="0"/>
-        <c:ser>
-          <c:idx val="0"/>
-          <c:order val="0"/>
-          <c:tx>
-            <c:strRef>
-              <c:f>Sheet1!$B$1</c:f>
-              <c:strCache>
-                <c:ptCount val="1"/>
-                <c:pt idx="0">
-                  <c:v>AED bn</c:v>
-                </c:pt>
-              </c:strCache>
-            </c:strRef>
-          </c:tx>
-          <c:spPr>
-            <a:solidFill>
-              <a:srgbClr val="C9A24B"/>
-            </a:solidFill>
-            <a:effectLst/>
-          </c:spPr>
-          <c:invertIfNegative val="0"/>
-          <c:dLbls>
-            <c:numFmt formatCode="#,##0" sourceLinked="0"/>
-            <c:txPr>
-              <a:bodyPr/>
-              <a:lstStyle/>
-              <a:p>
-                <a:pPr>
-                  <a:defRPr b="0" i="0" strike="noStrike" sz="1000" u="none">
-                    <a:solidFill>
-                      <a:srgbClr val="1E293B"/>
-                    </a:solidFill>
-                    <a:latin typeface="Calibri"/>
-                  </a:defRPr>
-                </a:pPr>
-              </a:p>
-            </c:txPr>
-            <c:showLegendKey val="0"/>
-            <c:showVal val="1"/>
-            <c:showCatName val="0"/>
-            <c:showSerName val="0"/>
-            <c:showPercent val="0"/>
-            <c:showBubbleSize val="0"/>
-            <c:showLeaderLines val="0"/>
-          </c:dLbls>
-          <c:cat>
-            <c:multiLvlStrRef>
-              <c:f>Sheet1!$A$2:$A$6</c:f>
-              <c:multiLvlStrCache>
-                <c:ptCount val="5"/>
-                <c:lvl>
-                  <c:pt idx="0">
-                    <c:v>wk-4</c:v>
-                  </c:pt>
-                  <c:pt idx="1">
-                    <c:v>wk-3</c:v>
-                  </c:pt>
-                  <c:pt idx="2">
-                    <c:v>wk-2</c:v>
-                  </c:pt>
-                  <c:pt idx="3">
-                    <c:v>wk-1</c:v>
-                  </c:pt>
-                  <c:pt idx="4">
-                    <c:v>this wk</c:v>
-                  </c:pt>
-                </c:lvl>
-              </c:multiLvlStrCache>
-            </c:multiLvlStrRef>
-          </c:cat>
-          <c:val>
-            <c:numRef>
-              <c:f>Sheet1!$B$2:$B$6</c:f>
-              <c:numCache>
-                <c:formatCode>General</c:formatCode>
-                <c:ptCount val="5"/>
-                <c:pt idx="0">
-                  <c:v>10</c:v>
-                </c:pt>
-                <c:pt idx="1">
-                  <c:v>14.7</c:v>
-                </c:pt>
-                <c:pt idx="2">
-                  <c:v>15.2</c:v>
-                </c:pt>
-                <c:pt idx="3">
-                  <c:v>21</c:v>
-                </c:pt>
-                <c:pt idx="4">
-                  <c:v>11.3</c:v>
-                </c:pt>
-              </c:numCache>
-            </c:numRef>
-          </c:val>
-        </c:ser>
-        <c:dLbls>
-          <c:numFmt formatCode="#,##0" sourceLinked="0"/>
-          <c:txPr>
-            <a:bodyPr/>
-            <a:lstStyle/>
-            <a:p>
-              <a:pPr>
-                <a:defRPr b="0" i="0" strike="noStrike" sz="1000" u="none">
-                  <a:solidFill>
-                    <a:srgbClr val="1E293B"/>
-                  </a:solidFill>
-                  <a:latin typeface="Calibri"/>
-                </a:defRPr>
-              </a:pPr>
-            </a:p>
-          </c:txPr>
-          <c:showLegendKey val="0"/>
-          <c:showVal val="1"/>
-          <c:showCatName val="0"/>
-          <c:showSerName val="0"/>
-          <c:showPercent val="0"/>
-          <c:showBubbleSize val="0"/>
-          <c:showLeaderLines val="0"/>
-        </c:dLbls>
-        <c:gapWidth val="55"/>
-        <c:overlap val="0"/>
-        <c:axId val="2094734554"/>
-        <c:axId val="2094734552"/>
-        <c:axId val="2094734556"/>
-      </c:barChart>
-      <c:catAx>
-        <c:axId val="2094734554"/>
-        <c:scaling>
-          <c:orientation val="minMax"/>
-        </c:scaling>
-        <c:delete val="0"/>
-        <c:axPos val="b"/>
-        <c:numFmt formatCode="General" sourceLinked="1"/>
-        <c:majorTickMark val="out"/>
-        <c:minorTickMark val="none"/>
-        <c:tickLblPos val="low"/>
-        <c:spPr>
-          <a:ln w="12700" cap="flat">
-            <a:solidFill>
-              <a:srgbClr val="888888"/>
-            </a:solidFill>
-            <a:prstDash val="solid"/>
-            <a:round/>
-          </a:ln>
-        </c:spPr>
-        <c:txPr>
-          <a:bodyPr/>
-          <a:lstStyle/>
-          <a:p>
-            <a:pPr>
-              <a:defRPr sz="1100" b="0" i="0" u="none" strike="noStrike">
-                <a:solidFill>
-                  <a:srgbClr val="64748B"/>
-                </a:solidFill>
-                <a:latin typeface="Calibri"/>
-              </a:defRPr>
-            </a:pPr>
-            <a:endParaRPr lang="en-US"/>
-          </a:p>
-        </c:txPr>
-        <c:crossAx val="2094734552"/>
-        <c:crosses val="autoZero"/>
-        <c:auto val="1"/>
-        <c:lblAlgn val="ctr"/>
-        <c:noMultiLvlLbl val="1"/>
-      </c:catAx>
-      <c:valAx>
-        <c:axId val="2094734552"/>
-        <c:scaling>
-          <c:orientation val="minMax"/>
-        </c:scaling>
-        <c:delete val="1"/>
-        <c:axPos val="l"/>
-        <c:numFmt formatCode="General" sourceLinked="0"/>
-        <c:majorTickMark val="out"/>
-        <c:minorTickMark val="none"/>
-        <c:tickLblPos val="nextTo"/>
-        <c:spPr>
-          <a:ln w="12700" cap="flat">
-            <a:solidFill>
-              <a:srgbClr val="888888"/>
-            </a:solidFill>
-            <a:prstDash val="solid"/>
-            <a:round/>
-          </a:ln>
-        </c:spPr>
-        <c:txPr>
-          <a:bodyPr/>
-          <a:lstStyle/>
-          <a:p>
-            <a:pPr>
-              <a:defRPr sz="1200" b="0" i="0" u="none" strike="noStrike">
-                <a:solidFill>
-                  <a:srgbClr val="000000"/>
-                </a:solidFill>
-                <a:latin typeface="Arial"/>
-              </a:defRPr>
-            </a:pPr>
-            <a:endParaRPr lang="en-US"/>
-          </a:p>
-        </c:txPr>
-        <c:crossAx val="2094734554"/>
-        <c:crosses val="autoZero"/>
-        <c:crossBetween val="between"/>
-      </c:valAx>
-      <c:spPr>
-        <a:noFill/>
-        <a:ln>
-          <a:noFill/>
-        </a:ln>
-        <a:effectLst/>
-      </c:spPr>
-    </c:plotArea>
-    <c:plotVisOnly val="1"/>
-    <c:dispBlanksAs val="span"/>
-  </c:chart>
-  <c:spPr>
-    <a:noFill/>
-    <a:ln>
-      <a:noFill/>
-    </a:ln>
-    <a:effectLst/>
-  </c:spPr>
-  <c:externalData r:id="rId1">
-    <c:autoUpdate val="0"/>
-  </c:externalData>
-</c:chartSpace>
-</file>
-
 <file path=ppt/notesMasters/notesMaster1.xml><?xml version="1.0" encoding="utf-8"?>
 <p:notesMaster xmlns:a="http://schemas.openxmlformats.org/drawingml/2006/main" xmlns:r="http://schemas.openxmlformats.org/officeDocument/2006/relationships" xmlns:p="http://schemas.openxmlformats.org/presentationml/2006/main">
   <p:cSld>
@@ -1547,7 +1306,7 @@
           <a:p>
             <a:r>
               <a:rPr lang="en-US" dirty="0"/>
-              <a:t>Don't drown them in stats — just convey scale. Billions change hands every week; there is more than enough business for everyone. These figures move week to week, so re-check the latest before presenting.</a:t>
+              <a:t>Convey scale without dated stats (this deck is reused for every new joiner). The message: the market is enormous, global, always producing new inventory, and growing long-term — there is more than enough business for everyone. If a trainer wants live figures, they can mention the latest weekly DLD number verbally, but keep the slides timeless.</a:t>
             </a:r>
             <a:endParaRPr lang="en-US" dirty="0"/>
           </a:p>
@@ -7683,7 +7442,7 @@
                 <a:ea typeface="Calibri" pitchFamily="34" charset="-122"/>
                 <a:cs typeface="Calibri" pitchFamily="34" charset="-120"/>
               </a:rPr>
-              <a:t>How much property changes hands in Dubai (verify weekly).</a:t>
+              <a:t>One of the busiest property markets on earth.</a:t>
             </a:r>
             <a:endParaRPr lang="en-US" sz="1400" dirty="0"/>
           </a:p>
@@ -7721,12 +7480,12 @@
         </p:nvSpPr>
         <p:spPr>
           <a:xfrm>
-            <a:off x="640080" y="1828800"/>
-            <a:ext cx="3454298" cy="1737360"/>
+            <a:off x="640080" y="1874520"/>
+            <a:ext cx="5272888" cy="1554480"/>
           </a:xfrm>
           <a:prstGeom prst="roundRect">
             <a:avLst>
-              <a:gd name="adj" fmla="val 5263"/>
+              <a:gd name="adj" fmla="val 5882"/>
             </a:avLst>
           </a:prstGeom>
           <a:solidFill>
@@ -7750,8 +7509,8 @@
         </p:nvSpPr>
         <p:spPr>
           <a:xfrm>
-            <a:off x="914400" y="2304288"/>
-            <a:ext cx="777240" cy="777240"/>
+            <a:off x="914400" y="2240280"/>
+            <a:ext cx="822960" cy="822960"/>
           </a:xfrm>
           <a:prstGeom prst="ellipse">
             <a:avLst/>
@@ -7785,8 +7544,8 @@
         </p:blipFill>
         <p:spPr>
           <a:xfrm>
-            <a:off x="1124255" y="2514143"/>
-            <a:ext cx="357530" cy="357530"/>
+            <a:off x="1136599" y="2462479"/>
+            <a:ext cx="378562" cy="378562"/>
           </a:xfrm>
           <a:prstGeom prst="rect">
             <a:avLst/>
@@ -7801,8 +7560,8 @@
         </p:nvSpPr>
         <p:spPr>
           <a:xfrm>
-            <a:off x="1828800" y="2194560"/>
-            <a:ext cx="2082698" cy="502920"/>
+            <a:off x="1920240" y="2167128"/>
+            <a:ext cx="3764128" cy="457200"/>
           </a:xfrm>
           <a:prstGeom prst="rect">
             <a:avLst/>
@@ -7818,17 +7577,17 @@
               <a:buNone/>
             </a:pPr>
             <a:r>
-              <a:rPr lang="en-US" sz="2200" b="1" dirty="0">
-                <a:solidFill>
-                  <a:srgbClr val="C9A24B"/>
+              <a:rPr lang="en-US" sz="1700" b="1" dirty="0">
+                <a:solidFill>
+                  <a:srgbClr val="0F1F3D"/>
                 </a:solidFill>
                 <a:latin typeface="Cambria" pitchFamily="34" charset="0"/>
                 <a:ea typeface="Cambria" pitchFamily="34" charset="-122"/>
                 <a:cs typeface="Cambria" pitchFamily="34" charset="-120"/>
               </a:rPr>
-              <a:t>AED 11.3B</a:t>
-            </a:r>
-            <a:endParaRPr lang="en-US" sz="2200" dirty="0"/>
+              <a:t>Billions every week</a:t>
+            </a:r>
+            <a:endParaRPr lang="en-US" sz="1700" dirty="0"/>
           </a:p>
         </p:txBody>
       </p:sp>
@@ -7840,8 +7599,8 @@
         </p:nvSpPr>
         <p:spPr>
           <a:xfrm>
-            <a:off x="1828800" y="2743200"/>
-            <a:ext cx="2082698" cy="548640"/>
+            <a:off x="1920240" y="2651760"/>
+            <a:ext cx="3764128" cy="685800"/>
           </a:xfrm>
           <a:prstGeom prst="rect">
             <a:avLst/>
@@ -7854,10 +7613,13 @@
           <a:lstStyle/>
           <a:p>
             <a:pPr indent="0" marL="0">
-              <a:buNone/>
-            </a:pPr>
-            <a:r>
-              <a:rPr lang="en-US" sz="1200" dirty="0">
+              <a:lnSpc>
+                <a:spcPct val="105000"/>
+              </a:lnSpc>
+              <a:buNone/>
+            </a:pPr>
+            <a:r>
+              <a:rPr lang="en-US" sz="1250" dirty="0">
                 <a:solidFill>
                   <a:srgbClr val="1E293B"/>
                 </a:solidFill>
@@ -7865,9 +7627,9 @@
                 <a:ea typeface="Calibri" pitchFamily="34" charset="-122"/>
                 <a:cs typeface="Calibri" pitchFamily="34" charset="-120"/>
               </a:rPr>
-              <a:t>in a single week</a:t>
-            </a:r>
-            <a:endParaRPr lang="en-US" sz="1200" dirty="0"/>
+              <a:t>Property worth billions of dirhams changes hands across Dubai — week after week.</a:t>
+            </a:r>
+            <a:endParaRPr lang="en-US" sz="1250" dirty="0"/>
           </a:p>
         </p:txBody>
       </p:sp>
@@ -7879,16 +7641,16 @@
         </p:nvSpPr>
         <p:spPr>
           <a:xfrm>
-            <a:off x="4277258" y="1828800"/>
-            <a:ext cx="3454298" cy="1737360"/>
+            <a:off x="6278728" y="1874520"/>
+            <a:ext cx="5272888" cy="1554480"/>
           </a:xfrm>
           <a:prstGeom prst="roundRect">
             <a:avLst>
-              <a:gd name="adj" fmla="val 5263"/>
+              <a:gd name="adj" fmla="val 5882"/>
             </a:avLst>
           </a:prstGeom>
           <a:solidFill>
-            <a:srgbClr val="F4F6FA"/>
+            <a:srgbClr val="EAF0F8"/>
           </a:solidFill>
           <a:ln/>
           <a:effectLst>
@@ -7908,8 +7670,8 @@
         </p:nvSpPr>
         <p:spPr>
           <a:xfrm>
-            <a:off x="4551578" y="2304288"/>
-            <a:ext cx="777240" cy="777240"/>
+            <a:off x="6553048" y="2240280"/>
+            <a:ext cx="822960" cy="822960"/>
           </a:xfrm>
           <a:prstGeom prst="ellipse">
             <a:avLst/>
@@ -7943,8 +7705,8 @@
         </p:blipFill>
         <p:spPr>
           <a:xfrm>
-            <a:off x="4761433" y="2514143"/>
-            <a:ext cx="357530" cy="357530"/>
+            <a:off x="6775247" y="2462479"/>
+            <a:ext cx="378562" cy="378562"/>
           </a:xfrm>
           <a:prstGeom prst="rect">
             <a:avLst/>
@@ -7959,8 +7721,8 @@
         </p:nvSpPr>
         <p:spPr>
           <a:xfrm>
-            <a:off x="5465978" y="2194560"/>
-            <a:ext cx="2082698" cy="502920"/>
+            <a:off x="7558888" y="2167128"/>
+            <a:ext cx="3764128" cy="457200"/>
           </a:xfrm>
           <a:prstGeom prst="rect">
             <a:avLst/>
@@ -7976,17 +7738,17 @@
               <a:buNone/>
             </a:pPr>
             <a:r>
-              <a:rPr lang="en-US" sz="2200" b="1" dirty="0">
-                <a:solidFill>
-                  <a:srgbClr val="C9A24B"/>
+              <a:rPr lang="en-US" sz="1700" b="1" dirty="0">
+                <a:solidFill>
+                  <a:srgbClr val="0F1F3D"/>
                 </a:solidFill>
                 <a:latin typeface="Cambria" pitchFamily="34" charset="0"/>
                 <a:ea typeface="Cambria" pitchFamily="34" charset="-122"/>
                 <a:cs typeface="Cambria" pitchFamily="34" charset="-120"/>
               </a:rPr>
-              <a:t>AED 252B</a:t>
-            </a:r>
-            <a:endParaRPr lang="en-US" sz="2200" dirty="0"/>
+              <a:t>A world of buyers</a:t>
+            </a:r>
+            <a:endParaRPr lang="en-US" sz="1700" dirty="0"/>
           </a:p>
         </p:txBody>
       </p:sp>
@@ -7998,8 +7760,8 @@
         </p:nvSpPr>
         <p:spPr>
           <a:xfrm>
-            <a:off x="5465978" y="2743200"/>
-            <a:ext cx="2082698" cy="548640"/>
+            <a:off x="7558888" y="2651760"/>
+            <a:ext cx="3764128" cy="685800"/>
           </a:xfrm>
           <a:prstGeom prst="rect">
             <a:avLst/>
@@ -8012,10 +7774,13 @@
           <a:lstStyle/>
           <a:p>
             <a:pPr indent="0" marL="0">
-              <a:buNone/>
-            </a:pPr>
-            <a:r>
-              <a:rPr lang="en-US" sz="1200" dirty="0">
+              <a:lnSpc>
+                <a:spcPct val="105000"/>
+              </a:lnSpc>
+              <a:buNone/>
+            </a:pPr>
+            <a:r>
+              <a:rPr lang="en-US" sz="1250" dirty="0">
                 <a:solidFill>
                   <a:srgbClr val="1E293B"/>
                 </a:solidFill>
@@ -8023,9 +7788,9 @@
                 <a:ea typeface="Calibri" pitchFamily="34" charset="-122"/>
                 <a:cs typeface="Calibri" pitchFamily="34" charset="-120"/>
               </a:rPr>
-              <a:t>in just 3 months (Q1 2026)</a:t>
-            </a:r>
-            <a:endParaRPr lang="en-US" sz="1200" dirty="0"/>
+              <a:t>People from 200+ nationalities live here. Your clients can come from anywhere.</a:t>
+            </a:r>
+            <a:endParaRPr lang="en-US" sz="1250" dirty="0"/>
           </a:p>
         </p:txBody>
       </p:sp>
@@ -8037,12 +7802,12 @@
         </p:nvSpPr>
         <p:spPr>
           <a:xfrm>
-            <a:off x="7914437" y="1828800"/>
-            <a:ext cx="3454298" cy="1737360"/>
+            <a:off x="640080" y="3657600"/>
+            <a:ext cx="5272888" cy="1554480"/>
           </a:xfrm>
           <a:prstGeom prst="roundRect">
             <a:avLst>
-              <a:gd name="adj" fmla="val 5263"/>
+              <a:gd name="adj" fmla="val 5882"/>
             </a:avLst>
           </a:prstGeom>
           <a:solidFill>
@@ -8066,8 +7831,8 @@
         </p:nvSpPr>
         <p:spPr>
           <a:xfrm>
-            <a:off x="8188757" y="2304288"/>
-            <a:ext cx="777240" cy="777240"/>
+            <a:off x="914400" y="4023360"/>
+            <a:ext cx="822960" cy="822960"/>
           </a:xfrm>
           <a:prstGeom prst="ellipse">
             <a:avLst/>
@@ -8101,8 +7866,8 @@
         </p:blipFill>
         <p:spPr>
           <a:xfrm>
-            <a:off x="8398612" y="2514143"/>
-            <a:ext cx="357530" cy="357530"/>
+            <a:off x="1136599" y="4245559"/>
+            <a:ext cx="378562" cy="378562"/>
           </a:xfrm>
           <a:prstGeom prst="rect">
             <a:avLst/>
@@ -8117,8 +7882,8 @@
         </p:nvSpPr>
         <p:spPr>
           <a:xfrm>
-            <a:off x="9103157" y="2194560"/>
-            <a:ext cx="2082698" cy="502920"/>
+            <a:off x="1920240" y="3950208"/>
+            <a:ext cx="3764128" cy="457200"/>
           </a:xfrm>
           <a:prstGeom prst="rect">
             <a:avLst/>
@@ -8134,17 +7899,17 @@
               <a:buNone/>
             </a:pPr>
             <a:r>
-              <a:rPr lang="en-US" sz="2200" b="1" dirty="0">
-                <a:solidFill>
-                  <a:srgbClr val="C9A24B"/>
+              <a:rPr lang="en-US" sz="1700" b="1" dirty="0">
+                <a:solidFill>
+                  <a:srgbClr val="0F1F3D"/>
                 </a:solidFill>
                 <a:latin typeface="Cambria" pitchFamily="34" charset="0"/>
                 <a:ea typeface="Cambria" pitchFamily="34" charset="-122"/>
                 <a:cs typeface="Cambria" pitchFamily="34" charset="-120"/>
               </a:rPr>
-              <a:t>AED 682.5B</a:t>
-            </a:r>
-            <a:endParaRPr lang="en-US" sz="2200" dirty="0"/>
+              <a:t>Always building</a:t>
+            </a:r>
+            <a:endParaRPr lang="en-US" sz="1700" dirty="0"/>
           </a:p>
         </p:txBody>
       </p:sp>
@@ -8156,8 +7921,8 @@
         </p:nvSpPr>
         <p:spPr>
           <a:xfrm>
-            <a:off x="9103157" y="2743200"/>
-            <a:ext cx="2082698" cy="548640"/>
+            <a:off x="1920240" y="4434840"/>
+            <a:ext cx="3764128" cy="685800"/>
           </a:xfrm>
           <a:prstGeom prst="rect">
             <a:avLst/>
@@ -8170,10 +7935,13 @@
           <a:lstStyle/>
           <a:p>
             <a:pPr indent="0" marL="0">
-              <a:buNone/>
-            </a:pPr>
-            <a:r>
-              <a:rPr lang="en-US" sz="1200" dirty="0">
+              <a:lnSpc>
+                <a:spcPct val="105000"/>
+              </a:lnSpc>
+              <a:buNone/>
+            </a:pPr>
+            <a:r>
+              <a:rPr lang="en-US" sz="1250" dirty="0">
                 <a:solidFill>
                   <a:srgbClr val="1E293B"/>
                 </a:solidFill>
@@ -8181,22 +7949,102 @@
                 <a:ea typeface="Calibri" pitchFamily="34" charset="-122"/>
                 <a:cs typeface="Calibri" pitchFamily="34" charset="-120"/>
               </a:rPr>
-              <a:t>in 2025 — a record year</a:t>
-            </a:r>
-            <a:endParaRPr lang="en-US" sz="1200" dirty="0"/>
-          </a:p>
-        </p:txBody>
-      </p:sp>
-      <p:sp>
-        <p:nvSpPr>
-          <p:cNvPr id="20" name="Text 14"/>
-          <p:cNvSpPr/>
-          <p:nvPr/>
-        </p:nvSpPr>
-        <p:spPr>
-          <a:xfrm>
-            <a:off x="640080" y="3794760"/>
-            <a:ext cx="10911535" cy="320040"/>
+              <a:t>New communities and landmark towers launch constantly — fresh homes to sell.</a:t>
+            </a:r>
+            <a:endParaRPr lang="en-US" sz="1250" dirty="0"/>
+          </a:p>
+        </p:txBody>
+      </p:sp>
+      <p:sp>
+        <p:nvSpPr>
+          <p:cNvPr id="20" name="Shape 14"/>
+          <p:cNvSpPr/>
+          <p:nvPr/>
+        </p:nvSpPr>
+        <p:spPr>
+          <a:xfrm>
+            <a:off x="6278728" y="3657600"/>
+            <a:ext cx="5272888" cy="1554480"/>
+          </a:xfrm>
+          <a:prstGeom prst="roundRect">
+            <a:avLst>
+              <a:gd name="adj" fmla="val 5882"/>
+            </a:avLst>
+          </a:prstGeom>
+          <a:solidFill>
+            <a:srgbClr val="EAF0F8"/>
+          </a:solidFill>
+          <a:ln/>
+          <a:effectLst>
+            <a:outerShdw sx="100000" sy="100000" kx="0" ky="0" algn="bl" rotWithShape="0" blurRad="114300" dist="38100" dir="5400000">
+              <a:srgbClr val="9AA3B2">
+                <a:alpha val="40000"/>
+              </a:srgbClr>
+            </a:outerShdw>
+          </a:effectLst>
+        </p:spPr>
+      </p:sp>
+      <p:sp>
+        <p:nvSpPr>
+          <p:cNvPr id="21" name="Shape 15"/>
+          <p:cNvSpPr/>
+          <p:nvPr/>
+        </p:nvSpPr>
+        <p:spPr>
+          <a:xfrm>
+            <a:off x="6553048" y="4023360"/>
+            <a:ext cx="822960" cy="822960"/>
+          </a:xfrm>
+          <a:prstGeom prst="ellipse">
+            <a:avLst/>
+          </a:prstGeom>
+          <a:solidFill>
+            <a:srgbClr val="C9A24B"/>
+          </a:solidFill>
+          <a:ln/>
+          <a:effectLst>
+            <a:outerShdw sx="100000" sy="100000" kx="0" ky="0" algn="bl" rotWithShape="0" blurRad="114300" dist="38100" dir="5400000">
+              <a:srgbClr val="9AA3B2">
+                <a:alpha val="40000"/>
+              </a:srgbClr>
+            </a:outerShdw>
+          </a:effectLst>
+        </p:spPr>
+      </p:sp>
+      <p:pic>
+        <p:nvPicPr>
+          <p:cNvPr id="22" name="Image 4" descr="preencoded.png">    </p:cNvPr>
+          <p:cNvPicPr>
+            <a:picLocks noChangeAspect="1"/>
+          </p:cNvPicPr>
+          <p:nvPr/>
+        </p:nvPicPr>
+        <p:blipFill>
+          <a:blip r:embed="rId5"/>
+          <a:stretch>
+            <a:fillRect/>
+          </a:stretch>
+        </p:blipFill>
+        <p:spPr>
+          <a:xfrm>
+            <a:off x="6775247" y="4245559"/>
+            <a:ext cx="378562" cy="378562"/>
+          </a:xfrm>
+          <a:prstGeom prst="rect">
+            <a:avLst/>
+          </a:prstGeom>
+        </p:spPr>
+      </p:pic>
+      <p:sp>
+        <p:nvSpPr>
+          <p:cNvPr id="23" name="Text 16"/>
+          <p:cNvSpPr/>
+          <p:nvPr/>
+        </p:nvSpPr>
+        <p:spPr>
+          <a:xfrm>
+            <a:off x="7558888" y="3950208"/>
+            <a:ext cx="3764128" cy="457200"/>
           </a:xfrm>
           <a:prstGeom prst="rect">
             <a:avLst/>
@@ -8212,36 +8060,62 @@
               <a:buNone/>
             </a:pPr>
             <a:r>
-              <a:rPr lang="en-US" sz="1300" b="1" dirty="0">
+              <a:rPr lang="en-US" sz="1700" b="1" dirty="0">
                 <a:solidFill>
                   <a:srgbClr val="0F1F3D"/>
+                </a:solidFill>
+                <a:latin typeface="Cambria" pitchFamily="34" charset="0"/>
+                <a:ea typeface="Cambria" pitchFamily="34" charset="-122"/>
+                <a:cs typeface="Cambria" pitchFamily="34" charset="-120"/>
+              </a:rPr>
+              <a:t>Long-term demand</a:t>
+            </a:r>
+            <a:endParaRPr lang="en-US" sz="1700" dirty="0"/>
+          </a:p>
+        </p:txBody>
+      </p:sp>
+      <p:sp>
+        <p:nvSpPr>
+          <p:cNvPr id="24" name="Text 17"/>
+          <p:cNvSpPr/>
+          <p:nvPr/>
+        </p:nvSpPr>
+        <p:spPr>
+          <a:xfrm>
+            <a:off x="7558888" y="4434840"/>
+            <a:ext cx="3764128" cy="685800"/>
+          </a:xfrm>
+          <a:prstGeom prst="rect">
+            <a:avLst/>
+          </a:prstGeom>
+          <a:noFill/>
+          <a:ln/>
+        </p:spPr>
+        <p:txBody>
+          <a:bodyPr wrap="square" rtlCol="0" anchor="t"/>
+          <a:lstStyle/>
+          <a:p>
+            <a:pPr indent="0" marL="0">
+              <a:lnSpc>
+                <a:spcPct val="105000"/>
+              </a:lnSpc>
+              <a:buNone/>
+            </a:pPr>
+            <a:r>
+              <a:rPr lang="en-US" sz="1250" dirty="0">
+                <a:solidFill>
+                  <a:srgbClr val="1E293B"/>
                 </a:solidFill>
                 <a:latin typeface="Calibri" pitchFamily="34" charset="0"/>
                 <a:ea typeface="Calibri" pitchFamily="34" charset="-122"/>
                 <a:cs typeface="Calibri" pitchFamily="34" charset="-120"/>
               </a:rPr>
-              <a:t>Weekly sales (AED billions)</a:t>
-            </a:r>
-            <a:endParaRPr lang="en-US" sz="1300" dirty="0"/>
-          </a:p>
-        </p:txBody>
-      </p:sp>
-      <p:graphicFrame>
-        <p:nvGraphicFramePr>
-          <p:cNvPr id="21" name="Chart 0" descr=""/>
-          <p:cNvGraphicFramePr/>
-          <p:nvPr/>
-        </p:nvGraphicFramePr>
-        <p:xfrm>
-          <a:off x="640080" y="4114800"/>
-          <a:ext cx="10911535" cy="2148840"/>
-        </p:xfrm>
-        <a:graphic xmlns:a="http://schemas.openxmlformats.org/drawingml/2006/main">
-          <a:graphicData uri="http://schemas.openxmlformats.org/drawingml/2006/chart">
-            <c:chart xmlns:c="http://schemas.openxmlformats.org/drawingml/2006/chart" r:id="rId5"/>
-          </a:graphicData>
-        </a:graphic>
-      </p:graphicFrame>
+              <a:t>Population and investment keep climbing, year after year.</a:t>
+            </a:r>
+            <a:endParaRPr lang="en-US" sz="1250" dirty="0"/>
+          </a:p>
+        </p:txBody>
+      </p:sp>
     </p:spTree>
   </p:cSld>
   <p:clrMapOvr>

</xml_diff>

<commit_message>
Day 1 slides 5-6: add proof/example line per point; add evergreen Dubai population growth numbers
</commit_message>
<xml_diff>
--- a/bridges-allies/BridgesAllies_OffPlan_Training_Day1.pptx
+++ b/bridges-allies/BridgesAllies_OffPlan_Training_Day1.pptx
@@ -1218,7 +1218,11 @@
           <a:p>
             <a:r>
               <a:rPr lang="en-US" dirty="0"/>
-              <a:t>Keep this conversational. These are the everyday reasons buyers from around the world choose Dubai — tax-free returns, safety, connectivity, and momentum. You'll repeat these to clients constantly.</a:t>
+              <a:t>Conversational and confident. Expand each with the real-world example:
+• Tax-free: clients keep all rent and resale gains.
+• Safe &amp; stable: even with regional conflict (e.g. recent tensions), markets just CORRECT — like stocks. Dips are normal and temporary; the disciplined 'bulls' buy during the dip and profit on the recovery, while Dubai's regulation (escrow, DLD) protects buyers throughout.
+• Global hub: 200+ nationalities, ~8 hours from two-thirds of the world's population.
+• Growth: point out the window — new districts keep being built.</a:t>
             </a:r>
             <a:endParaRPr lang="en-US" dirty="0"/>
           </a:p>
@@ -1306,7 +1310,7 @@
           <a:p>
             <a:r>
               <a:rPr lang="en-US" dirty="0"/>
-              <a:t>Convey scale without dated stats (this deck is reused for every new joiner). The message: the market is enormous, global, always producing new inventory, and growing long-term — there is more than enough business for everyone. If a trainer wants live figures, they can mention the latest weekly DLD number verbally, but keep the slides timeless.</a:t>
+              <a:t>Scale with durable proof (reused for every joiner). The population numbers are the anchor: Dubai passed 4 million residents in 2025, added ~200,000 people in a single year (its fastest ever), and targets 5.8 million by 2040 — every new resident is a future tenant or buyer, which is exactly why demand keeps rising. Keep figures round and trend-based, not month-to-month.</a:t>
             </a:r>
             <a:endParaRPr lang="en-US" dirty="0"/>
           </a:p>
@@ -6664,7 +6668,7 @@
                 <a:ea typeface="Calibri" pitchFamily="34" charset="-122"/>
                 <a:cs typeface="Calibri" pitchFamily="34" charset="-120"/>
               </a:rPr>
-              <a:t>Simple reasons your clients already love.</a:t>
+              <a:t>Simple reasons — with proof you can repeat to clients.</a:t>
             </a:r>
             <a:endParaRPr lang="en-US" sz="1400" dirty="0"/>
           </a:p>
@@ -6702,12 +6706,12 @@
         </p:nvSpPr>
         <p:spPr>
           <a:xfrm>
-            <a:off x="640080" y="1874520"/>
-            <a:ext cx="5272888" cy="1554480"/>
+            <a:off x="640080" y="1783080"/>
+            <a:ext cx="5272888" cy="1828800"/>
           </a:xfrm>
           <a:prstGeom prst="roundRect">
             <a:avLst>
-              <a:gd name="adj" fmla="val 5882"/>
+              <a:gd name="adj" fmla="val 5000"/>
             </a:avLst>
           </a:prstGeom>
           <a:solidFill>
@@ -6731,8 +6735,8 @@
         </p:nvSpPr>
         <p:spPr>
           <a:xfrm>
-            <a:off x="914400" y="2240280"/>
-            <a:ext cx="822960" cy="822960"/>
+            <a:off x="914400" y="2093976"/>
+            <a:ext cx="749808" cy="749808"/>
           </a:xfrm>
           <a:prstGeom prst="ellipse">
             <a:avLst/>
@@ -6766,8 +6770,8 @@
         </p:blipFill>
         <p:spPr>
           <a:xfrm>
-            <a:off x="1136599" y="2462479"/>
-            <a:ext cx="378562" cy="378562"/>
+            <a:off x="1116848" y="2296424"/>
+            <a:ext cx="344912" cy="344912"/>
           </a:xfrm>
           <a:prstGeom prst="rect">
             <a:avLst/>
@@ -6782,8 +6786,8 @@
         </p:nvSpPr>
         <p:spPr>
           <a:xfrm>
-            <a:off x="1920240" y="2167128"/>
-            <a:ext cx="3764128" cy="457200"/>
+            <a:off x="1847088" y="2002536"/>
+            <a:ext cx="3855568" cy="384048"/>
           </a:xfrm>
           <a:prstGeom prst="rect">
             <a:avLst/>
@@ -6799,7 +6803,7 @@
               <a:buNone/>
             </a:pPr>
             <a:r>
-              <a:rPr lang="en-US" sz="1700" b="1" dirty="0">
+              <a:rPr lang="en-US" sz="1600" b="1" dirty="0">
                 <a:solidFill>
                   <a:srgbClr val="0F1F3D"/>
                 </a:solidFill>
@@ -6809,7 +6813,7 @@
               </a:rPr>
               <a:t>Tax-free income</a:t>
             </a:r>
-            <a:endParaRPr lang="en-US" sz="1700" dirty="0"/>
+            <a:endParaRPr lang="en-US" sz="1600" dirty="0"/>
           </a:p>
         </p:txBody>
       </p:sp>
@@ -6821,8 +6825,8 @@
         </p:nvSpPr>
         <p:spPr>
           <a:xfrm>
-            <a:off x="1920240" y="2651760"/>
-            <a:ext cx="3764128" cy="685800"/>
+            <a:off x="1847088" y="2386584"/>
+            <a:ext cx="3855568" cy="365760"/>
           </a:xfrm>
           <a:prstGeom prst="rect">
             <a:avLst/>
@@ -6835,13 +6839,10 @@
           <a:lstStyle/>
           <a:p>
             <a:pPr indent="0" marL="0">
-              <a:lnSpc>
-                <a:spcPct val="105000"/>
-              </a:lnSpc>
-              <a:buNone/>
-            </a:pPr>
-            <a:r>
-              <a:rPr lang="en-US" sz="1250" dirty="0">
+              <a:buNone/>
+            </a:pPr>
+            <a:r>
+              <a:rPr lang="en-US" sz="1150" dirty="0">
                 <a:solidFill>
                   <a:srgbClr val="1E293B"/>
                 </a:solidFill>
@@ -6849,26 +6850,85 @@
                 <a:ea typeface="Calibri" pitchFamily="34" charset="-122"/>
                 <a:cs typeface="Calibri" pitchFamily="34" charset="-120"/>
               </a:rPr>
-              <a:t>No personal income tax and no annual property tax on what they earn.</a:t>
-            </a:r>
-            <a:endParaRPr lang="en-US" sz="1250" dirty="0"/>
-          </a:p>
-        </p:txBody>
-      </p:sp>
-      <p:sp>
-        <p:nvSpPr>
-          <p:cNvPr id="10" name="Shape 6"/>
-          <p:cNvSpPr/>
-          <p:nvPr/>
-        </p:nvSpPr>
-        <p:spPr>
-          <a:xfrm>
-            <a:off x="6278728" y="1874520"/>
-            <a:ext cx="5272888" cy="1554480"/>
+              <a:t>No income tax, no annual property tax.</a:t>
+            </a:r>
+            <a:endParaRPr lang="en-US" sz="1150" dirty="0"/>
+          </a:p>
+        </p:txBody>
+      </p:sp>
+      <p:sp>
+        <p:nvSpPr>
+          <p:cNvPr id="10" name="Text 6"/>
+          <p:cNvSpPr/>
+          <p:nvPr/>
+        </p:nvSpPr>
+        <p:spPr>
+          <a:xfrm>
+            <a:off x="1847088" y="2807208"/>
+            <a:ext cx="3855568" cy="676656"/>
+          </a:xfrm>
+          <a:prstGeom prst="rect">
+            <a:avLst/>
+          </a:prstGeom>
+          <a:noFill/>
+          <a:ln/>
+        </p:spPr>
+        <p:txBody>
+          <a:bodyPr wrap="square" rtlCol="0" anchor="t"/>
+          <a:lstStyle/>
+          <a:p>
+            <a:pPr indent="0" marL="0">
+              <a:lnSpc>
+                <a:spcPct val="104000"/>
+              </a:lnSpc>
+              <a:buNone/>
+            </a:pPr>
+            <a:r>
+              <a:rPr lang="en-US" sz="1050" b="1" dirty="0">
+                <a:solidFill>
+                  <a:srgbClr val="C9A24B"/>
+                </a:solidFill>
+                <a:latin typeface="Calibri" pitchFamily="34" charset="0"/>
+                <a:ea typeface="Calibri" pitchFamily="34" charset="-122"/>
+                <a:cs typeface="Calibri" pitchFamily="34" charset="-120"/>
+              </a:rPr>
+              <a:t>→  </a:t>
+            </a:r>
+            <a:pPr indent="0" marL="0">
+              <a:lnSpc>
+                <a:spcPct val="104000"/>
+              </a:lnSpc>
+              <a:buNone/>
+            </a:pPr>
+            <a:r>
+              <a:rPr lang="en-US" sz="1050" i="1" dirty="0">
+                <a:solidFill>
+                  <a:srgbClr val="64748B"/>
+                </a:solidFill>
+                <a:latin typeface="Calibri" pitchFamily="34" charset="0"/>
+                <a:ea typeface="Calibri" pitchFamily="34" charset="-122"/>
+                <a:cs typeface="Calibri" pitchFamily="34" charset="-120"/>
+              </a:rPr>
+              <a:t>Keep 100% of your rent and resale profit.</a:t>
+            </a:r>
+            <a:endParaRPr lang="en-US" sz="1050" dirty="0"/>
+          </a:p>
+        </p:txBody>
+      </p:sp>
+      <p:sp>
+        <p:nvSpPr>
+          <p:cNvPr id="11" name="Shape 7"/>
+          <p:cNvSpPr/>
+          <p:nvPr/>
+        </p:nvSpPr>
+        <p:spPr>
+          <a:xfrm>
+            <a:off x="6278728" y="1783080"/>
+            <a:ext cx="5272888" cy="1828800"/>
           </a:xfrm>
           <a:prstGeom prst="roundRect">
             <a:avLst>
-              <a:gd name="adj" fmla="val 5882"/>
+              <a:gd name="adj" fmla="val 5000"/>
             </a:avLst>
           </a:prstGeom>
           <a:solidFill>
@@ -6886,14 +6946,14 @@
       </p:sp>
       <p:sp>
         <p:nvSpPr>
-          <p:cNvPr id="11" name="Shape 7"/>
-          <p:cNvSpPr/>
-          <p:nvPr/>
-        </p:nvSpPr>
-        <p:spPr>
-          <a:xfrm>
-            <a:off x="6553048" y="2240280"/>
-            <a:ext cx="822960" cy="822960"/>
+          <p:cNvPr id="12" name="Shape 8"/>
+          <p:cNvSpPr/>
+          <p:nvPr/>
+        </p:nvSpPr>
+        <p:spPr>
+          <a:xfrm>
+            <a:off x="6553048" y="2093976"/>
+            <a:ext cx="749808" cy="749808"/>
           </a:xfrm>
           <a:prstGeom prst="ellipse">
             <a:avLst/>
@@ -6913,7 +6973,7 @@
       </p:sp>
       <p:pic>
         <p:nvPicPr>
-          <p:cNvPr id="12" name="Image 2" descr="preencoded.png">    </p:cNvPr>
+          <p:cNvPr id="13" name="Image 2" descr="preencoded.png">    </p:cNvPr>
           <p:cNvPicPr>
             <a:picLocks noChangeAspect="1"/>
           </p:cNvPicPr>
@@ -6927,8 +6987,8 @@
         </p:blipFill>
         <p:spPr>
           <a:xfrm>
-            <a:off x="6775247" y="2462479"/>
-            <a:ext cx="378562" cy="378562"/>
+            <a:off x="6755496" y="2296424"/>
+            <a:ext cx="344912" cy="344912"/>
           </a:xfrm>
           <a:prstGeom prst="rect">
             <a:avLst/>
@@ -6937,14 +6997,14 @@
       </p:pic>
       <p:sp>
         <p:nvSpPr>
-          <p:cNvPr id="13" name="Text 8"/>
-          <p:cNvSpPr/>
-          <p:nvPr/>
-        </p:nvSpPr>
-        <p:spPr>
-          <a:xfrm>
-            <a:off x="7558888" y="2167128"/>
-            <a:ext cx="3764128" cy="457200"/>
+          <p:cNvPr id="14" name="Text 9"/>
+          <p:cNvSpPr/>
+          <p:nvPr/>
+        </p:nvSpPr>
+        <p:spPr>
+          <a:xfrm>
+            <a:off x="7485736" y="2002536"/>
+            <a:ext cx="3855568" cy="384048"/>
           </a:xfrm>
           <a:prstGeom prst="rect">
             <a:avLst/>
@@ -6960,7 +7020,7 @@
               <a:buNone/>
             </a:pPr>
             <a:r>
-              <a:rPr lang="en-US" sz="1700" b="1" dirty="0">
+              <a:rPr lang="en-US" sz="1600" b="1" dirty="0">
                 <a:solidFill>
                   <a:srgbClr val="0F1F3D"/>
                 </a:solidFill>
@@ -6970,20 +7030,20 @@
               </a:rPr>
               <a:t>Safe &amp; stable</a:t>
             </a:r>
-            <a:endParaRPr lang="en-US" sz="1700" dirty="0"/>
-          </a:p>
-        </p:txBody>
-      </p:sp>
-      <p:sp>
-        <p:nvSpPr>
-          <p:cNvPr id="14" name="Text 9"/>
-          <p:cNvSpPr/>
-          <p:nvPr/>
-        </p:nvSpPr>
-        <p:spPr>
-          <a:xfrm>
-            <a:off x="7558888" y="2651760"/>
-            <a:ext cx="3764128" cy="685800"/>
+            <a:endParaRPr lang="en-US" sz="1600" dirty="0"/>
+          </a:p>
+        </p:txBody>
+      </p:sp>
+      <p:sp>
+        <p:nvSpPr>
+          <p:cNvPr id="15" name="Text 10"/>
+          <p:cNvSpPr/>
+          <p:nvPr/>
+        </p:nvSpPr>
+        <p:spPr>
+          <a:xfrm>
+            <a:off x="7485736" y="2386584"/>
+            <a:ext cx="3855568" cy="365760"/>
           </a:xfrm>
           <a:prstGeom prst="rect">
             <a:avLst/>
@@ -6996,13 +7056,10 @@
           <a:lstStyle/>
           <a:p>
             <a:pPr indent="0" marL="0">
-              <a:lnSpc>
-                <a:spcPct val="105000"/>
-              </a:lnSpc>
-              <a:buNone/>
-            </a:pPr>
-            <a:r>
-              <a:rPr lang="en-US" sz="1250" dirty="0">
+              <a:buNone/>
+            </a:pPr>
+            <a:r>
+              <a:rPr lang="en-US" sz="1150" dirty="0">
                 <a:solidFill>
                   <a:srgbClr val="1E293B"/>
                 </a:solidFill>
@@ -7010,26 +7067,85 @@
                 <a:ea typeface="Calibri" pitchFamily="34" charset="-122"/>
                 <a:cs typeface="Calibri" pitchFamily="34" charset="-120"/>
               </a:rPr>
-              <a:t>One of the world's safest cities, with a trusted, regulated market.</a:t>
-            </a:r>
-            <a:endParaRPr lang="en-US" sz="1250" dirty="0"/>
-          </a:p>
-        </p:txBody>
-      </p:sp>
-      <p:sp>
-        <p:nvSpPr>
-          <p:cNvPr id="15" name="Shape 10"/>
-          <p:cNvSpPr/>
-          <p:nvPr/>
-        </p:nvSpPr>
-        <p:spPr>
-          <a:xfrm>
-            <a:off x="640080" y="3657600"/>
-            <a:ext cx="5272888" cy="1554480"/>
+              <a:t>One of the world's safest, best-regulated cities.</a:t>
+            </a:r>
+            <a:endParaRPr lang="en-US" sz="1150" dirty="0"/>
+          </a:p>
+        </p:txBody>
+      </p:sp>
+      <p:sp>
+        <p:nvSpPr>
+          <p:cNvPr id="16" name="Text 11"/>
+          <p:cNvSpPr/>
+          <p:nvPr/>
+        </p:nvSpPr>
+        <p:spPr>
+          <a:xfrm>
+            <a:off x="7485736" y="2807208"/>
+            <a:ext cx="3855568" cy="676656"/>
+          </a:xfrm>
+          <a:prstGeom prst="rect">
+            <a:avLst/>
+          </a:prstGeom>
+          <a:noFill/>
+          <a:ln/>
+        </p:spPr>
+        <p:txBody>
+          <a:bodyPr wrap="square" rtlCol="0" anchor="t"/>
+          <a:lstStyle/>
+          <a:p>
+            <a:pPr indent="0" marL="0">
+              <a:lnSpc>
+                <a:spcPct val="104000"/>
+              </a:lnSpc>
+              <a:buNone/>
+            </a:pPr>
+            <a:r>
+              <a:rPr lang="en-US" sz="1050" b="1" dirty="0">
+                <a:solidFill>
+                  <a:srgbClr val="C9A24B"/>
+                </a:solidFill>
+                <a:latin typeface="Calibri" pitchFamily="34" charset="0"/>
+                <a:ea typeface="Calibri" pitchFamily="34" charset="-122"/>
+                <a:cs typeface="Calibri" pitchFamily="34" charset="-120"/>
+              </a:rPr>
+              <a:t>→  </a:t>
+            </a:r>
+            <a:pPr indent="0" marL="0">
+              <a:lnSpc>
+                <a:spcPct val="104000"/>
+              </a:lnSpc>
+              <a:buNone/>
+            </a:pPr>
+            <a:r>
+              <a:rPr lang="en-US" sz="1050" i="1" dirty="0">
+                <a:solidFill>
+                  <a:srgbClr val="64748B"/>
+                </a:solidFill>
+                <a:latin typeface="Calibri" pitchFamily="34" charset="0"/>
+                <a:ea typeface="Calibri" pitchFamily="34" charset="-122"/>
+                <a:cs typeface="Calibri" pitchFamily="34" charset="-120"/>
+              </a:rPr>
+              <a:t>Global events cause short dips, then recovery — the patient win.</a:t>
+            </a:r>
+            <a:endParaRPr lang="en-US" sz="1050" dirty="0"/>
+          </a:p>
+        </p:txBody>
+      </p:sp>
+      <p:sp>
+        <p:nvSpPr>
+          <p:cNvPr id="17" name="Shape 12"/>
+          <p:cNvSpPr/>
+          <p:nvPr/>
+        </p:nvSpPr>
+        <p:spPr>
+          <a:xfrm>
+            <a:off x="640080" y="3794760"/>
+            <a:ext cx="5272888" cy="1828800"/>
           </a:xfrm>
           <a:prstGeom prst="roundRect">
             <a:avLst>
-              <a:gd name="adj" fmla="val 5882"/>
+              <a:gd name="adj" fmla="val 5000"/>
             </a:avLst>
           </a:prstGeom>
           <a:solidFill>
@@ -7047,14 +7163,14 @@
       </p:sp>
       <p:sp>
         <p:nvSpPr>
-          <p:cNvPr id="16" name="Shape 11"/>
-          <p:cNvSpPr/>
-          <p:nvPr/>
-        </p:nvSpPr>
-        <p:spPr>
-          <a:xfrm>
-            <a:off x="914400" y="4023360"/>
-            <a:ext cx="822960" cy="822960"/>
+          <p:cNvPr id="18" name="Shape 13"/>
+          <p:cNvSpPr/>
+          <p:nvPr/>
+        </p:nvSpPr>
+        <p:spPr>
+          <a:xfrm>
+            <a:off x="914400" y="4105656"/>
+            <a:ext cx="749808" cy="749808"/>
           </a:xfrm>
           <a:prstGeom prst="ellipse">
             <a:avLst/>
@@ -7074,7 +7190,7 @@
       </p:sp>
       <p:pic>
         <p:nvPicPr>
-          <p:cNvPr id="17" name="Image 3" descr="preencoded.png">    </p:cNvPr>
+          <p:cNvPr id="19" name="Image 3" descr="preencoded.png">    </p:cNvPr>
           <p:cNvPicPr>
             <a:picLocks noChangeAspect="1"/>
           </p:cNvPicPr>
@@ -7088,8 +7204,8 @@
         </p:blipFill>
         <p:spPr>
           <a:xfrm>
-            <a:off x="1136599" y="4245559"/>
-            <a:ext cx="378562" cy="378562"/>
+            <a:off x="1116848" y="4308104"/>
+            <a:ext cx="344912" cy="344912"/>
           </a:xfrm>
           <a:prstGeom prst="rect">
             <a:avLst/>
@@ -7098,14 +7214,14 @@
       </p:pic>
       <p:sp>
         <p:nvSpPr>
-          <p:cNvPr id="18" name="Text 12"/>
-          <p:cNvSpPr/>
-          <p:nvPr/>
-        </p:nvSpPr>
-        <p:spPr>
-          <a:xfrm>
-            <a:off x="1920240" y="3950208"/>
-            <a:ext cx="3764128" cy="457200"/>
+          <p:cNvPr id="20" name="Text 14"/>
+          <p:cNvSpPr/>
+          <p:nvPr/>
+        </p:nvSpPr>
+        <p:spPr>
+          <a:xfrm>
+            <a:off x="1847088" y="4014216"/>
+            <a:ext cx="3855568" cy="384048"/>
           </a:xfrm>
           <a:prstGeom prst="rect">
             <a:avLst/>
@@ -7121,7 +7237,7 @@
               <a:buNone/>
             </a:pPr>
             <a:r>
-              <a:rPr lang="en-US" sz="1700" b="1" dirty="0">
+              <a:rPr lang="en-US" sz="1600" b="1" dirty="0">
                 <a:solidFill>
                   <a:srgbClr val="0F1F3D"/>
                 </a:solidFill>
@@ -7131,20 +7247,20 @@
               </a:rPr>
               <a:t>A global hub</a:t>
             </a:r>
-            <a:endParaRPr lang="en-US" sz="1700" dirty="0"/>
-          </a:p>
-        </p:txBody>
-      </p:sp>
-      <p:sp>
-        <p:nvSpPr>
-          <p:cNvPr id="19" name="Text 13"/>
-          <p:cNvSpPr/>
-          <p:nvPr/>
-        </p:nvSpPr>
-        <p:spPr>
-          <a:xfrm>
-            <a:off x="1920240" y="4434840"/>
-            <a:ext cx="3764128" cy="685800"/>
+            <a:endParaRPr lang="en-US" sz="1600" dirty="0"/>
+          </a:p>
+        </p:txBody>
+      </p:sp>
+      <p:sp>
+        <p:nvSpPr>
+          <p:cNvPr id="21" name="Text 15"/>
+          <p:cNvSpPr/>
+          <p:nvPr/>
+        </p:nvSpPr>
+        <p:spPr>
+          <a:xfrm>
+            <a:off x="1847088" y="4398264"/>
+            <a:ext cx="3855568" cy="365760"/>
           </a:xfrm>
           <a:prstGeom prst="rect">
             <a:avLst/>
@@ -7157,13 +7273,10 @@
           <a:lstStyle/>
           <a:p>
             <a:pPr indent="0" marL="0">
-              <a:lnSpc>
-                <a:spcPct val="105000"/>
-              </a:lnSpc>
-              <a:buNone/>
-            </a:pPr>
-            <a:r>
-              <a:rPr lang="en-US" sz="1250" dirty="0">
+              <a:buNone/>
+            </a:pPr>
+            <a:r>
+              <a:rPr lang="en-US" sz="1150" dirty="0">
                 <a:solidFill>
                   <a:srgbClr val="1E293B"/>
                 </a:solidFill>
@@ -7171,26 +7284,85 @@
                 <a:ea typeface="Calibri" pitchFamily="34" charset="-122"/>
                 <a:cs typeface="Calibri" pitchFamily="34" charset="-120"/>
               </a:rPr>
-              <a:t>A few hours from most of the world — business, lifestyle, and travel.</a:t>
-            </a:r>
-            <a:endParaRPr lang="en-US" sz="1250" dirty="0"/>
-          </a:p>
-        </p:txBody>
-      </p:sp>
-      <p:sp>
-        <p:nvSpPr>
-          <p:cNvPr id="20" name="Shape 14"/>
-          <p:cNvSpPr/>
-          <p:nvPr/>
-        </p:nvSpPr>
-        <p:spPr>
-          <a:xfrm>
-            <a:off x="6278728" y="3657600"/>
-            <a:ext cx="5272888" cy="1554480"/>
+              <a:t>A few hours from most of the world.</a:t>
+            </a:r>
+            <a:endParaRPr lang="en-US" sz="1150" dirty="0"/>
+          </a:p>
+        </p:txBody>
+      </p:sp>
+      <p:sp>
+        <p:nvSpPr>
+          <p:cNvPr id="22" name="Text 16"/>
+          <p:cNvSpPr/>
+          <p:nvPr/>
+        </p:nvSpPr>
+        <p:spPr>
+          <a:xfrm>
+            <a:off x="1847088" y="4818888"/>
+            <a:ext cx="3855568" cy="676656"/>
+          </a:xfrm>
+          <a:prstGeom prst="rect">
+            <a:avLst/>
+          </a:prstGeom>
+          <a:noFill/>
+          <a:ln/>
+        </p:spPr>
+        <p:txBody>
+          <a:bodyPr wrap="square" rtlCol="0" anchor="t"/>
+          <a:lstStyle/>
+          <a:p>
+            <a:pPr indent="0" marL="0">
+              <a:lnSpc>
+                <a:spcPct val="104000"/>
+              </a:lnSpc>
+              <a:buNone/>
+            </a:pPr>
+            <a:r>
+              <a:rPr lang="en-US" sz="1050" b="1" dirty="0">
+                <a:solidFill>
+                  <a:srgbClr val="C9A24B"/>
+                </a:solidFill>
+                <a:latin typeface="Calibri" pitchFamily="34" charset="0"/>
+                <a:ea typeface="Calibri" pitchFamily="34" charset="-122"/>
+                <a:cs typeface="Calibri" pitchFamily="34" charset="-120"/>
+              </a:rPr>
+              <a:t>→  </a:t>
+            </a:r>
+            <a:pPr indent="0" marL="0">
+              <a:lnSpc>
+                <a:spcPct val="104000"/>
+              </a:lnSpc>
+              <a:buNone/>
+            </a:pPr>
+            <a:r>
+              <a:rPr lang="en-US" sz="1050" i="1" dirty="0">
+                <a:solidFill>
+                  <a:srgbClr val="64748B"/>
+                </a:solidFill>
+                <a:latin typeface="Calibri" pitchFamily="34" charset="0"/>
+                <a:ea typeface="Calibri" pitchFamily="34" charset="-122"/>
+                <a:cs typeface="Calibri" pitchFamily="34" charset="-120"/>
+              </a:rPr>
+              <a:t>200+ nationalities; ~8 hours from two-thirds of the planet.</a:t>
+            </a:r>
+            <a:endParaRPr lang="en-US" sz="1050" dirty="0"/>
+          </a:p>
+        </p:txBody>
+      </p:sp>
+      <p:sp>
+        <p:nvSpPr>
+          <p:cNvPr id="23" name="Shape 17"/>
+          <p:cNvSpPr/>
+          <p:nvPr/>
+        </p:nvSpPr>
+        <p:spPr>
+          <a:xfrm>
+            <a:off x="6278728" y="3794760"/>
+            <a:ext cx="5272888" cy="1828800"/>
           </a:xfrm>
           <a:prstGeom prst="roundRect">
             <a:avLst>
-              <a:gd name="adj" fmla="val 5882"/>
+              <a:gd name="adj" fmla="val 5000"/>
             </a:avLst>
           </a:prstGeom>
           <a:solidFill>
@@ -7208,14 +7380,14 @@
       </p:sp>
       <p:sp>
         <p:nvSpPr>
-          <p:cNvPr id="21" name="Shape 15"/>
-          <p:cNvSpPr/>
-          <p:nvPr/>
-        </p:nvSpPr>
-        <p:spPr>
-          <a:xfrm>
-            <a:off x="6553048" y="4023360"/>
-            <a:ext cx="822960" cy="822960"/>
+          <p:cNvPr id="24" name="Shape 18"/>
+          <p:cNvSpPr/>
+          <p:nvPr/>
+        </p:nvSpPr>
+        <p:spPr>
+          <a:xfrm>
+            <a:off x="6553048" y="4105656"/>
+            <a:ext cx="749808" cy="749808"/>
           </a:xfrm>
           <a:prstGeom prst="ellipse">
             <a:avLst/>
@@ -7235,7 +7407,7 @@
       </p:sp>
       <p:pic>
         <p:nvPicPr>
-          <p:cNvPr id="22" name="Image 4" descr="preencoded.png">    </p:cNvPr>
+          <p:cNvPr id="25" name="Image 4" descr="preencoded.png">    </p:cNvPr>
           <p:cNvPicPr>
             <a:picLocks noChangeAspect="1"/>
           </p:cNvPicPr>
@@ -7249,8 +7421,8 @@
         </p:blipFill>
         <p:spPr>
           <a:xfrm>
-            <a:off x="6775247" y="4245559"/>
-            <a:ext cx="378562" cy="378562"/>
+            <a:off x="6755496" y="4308104"/>
+            <a:ext cx="344912" cy="344912"/>
           </a:xfrm>
           <a:prstGeom prst="rect">
             <a:avLst/>
@@ -7259,14 +7431,14 @@
       </p:pic>
       <p:sp>
         <p:nvSpPr>
-          <p:cNvPr id="23" name="Text 16"/>
-          <p:cNvSpPr/>
-          <p:nvPr/>
-        </p:nvSpPr>
-        <p:spPr>
-          <a:xfrm>
-            <a:off x="7558888" y="3950208"/>
-            <a:ext cx="3764128" cy="457200"/>
+          <p:cNvPr id="26" name="Text 19"/>
+          <p:cNvSpPr/>
+          <p:nvPr/>
+        </p:nvSpPr>
+        <p:spPr>
+          <a:xfrm>
+            <a:off x="7485736" y="4014216"/>
+            <a:ext cx="3855568" cy="384048"/>
           </a:xfrm>
           <a:prstGeom prst="rect">
             <a:avLst/>
@@ -7282,7 +7454,7 @@
               <a:buNone/>
             </a:pPr>
             <a:r>
-              <a:rPr lang="en-US" sz="1700" b="1" dirty="0">
+              <a:rPr lang="en-US" sz="1600" b="1" dirty="0">
                 <a:solidFill>
                   <a:srgbClr val="0F1F3D"/>
                 </a:solidFill>
@@ -7292,20 +7464,20 @@
               </a:rPr>
               <a:t>Strong growth</a:t>
             </a:r>
-            <a:endParaRPr lang="en-US" sz="1700" dirty="0"/>
-          </a:p>
-        </p:txBody>
-      </p:sp>
-      <p:sp>
-        <p:nvSpPr>
-          <p:cNvPr id="24" name="Text 17"/>
-          <p:cNvSpPr/>
-          <p:nvPr/>
-        </p:nvSpPr>
-        <p:spPr>
-          <a:xfrm>
-            <a:off x="7558888" y="4434840"/>
-            <a:ext cx="3764128" cy="685800"/>
+            <a:endParaRPr lang="en-US" sz="1600" dirty="0"/>
+          </a:p>
+        </p:txBody>
+      </p:sp>
+      <p:sp>
+        <p:nvSpPr>
+          <p:cNvPr id="27" name="Text 20"/>
+          <p:cNvSpPr/>
+          <p:nvPr/>
+        </p:nvSpPr>
+        <p:spPr>
+          <a:xfrm>
+            <a:off x="7485736" y="4398264"/>
+            <a:ext cx="3855568" cy="365760"/>
           </a:xfrm>
           <a:prstGeom prst="rect">
             <a:avLst/>
@@ -7318,13 +7490,10 @@
           <a:lstStyle/>
           <a:p>
             <a:pPr indent="0" marL="0">
-              <a:lnSpc>
-                <a:spcPct val="105000"/>
-              </a:lnSpc>
-              <a:buNone/>
-            </a:pPr>
-            <a:r>
-              <a:rPr lang="en-US" sz="1250" dirty="0">
+              <a:buNone/>
+            </a:pPr>
+            <a:r>
+              <a:rPr lang="en-US" sz="1150" dirty="0">
                 <a:solidFill>
                   <a:srgbClr val="1E293B"/>
                 </a:solidFill>
@@ -7332,9 +7501,68 @@
                 <a:ea typeface="Calibri" pitchFamily="34" charset="-122"/>
                 <a:cs typeface="Calibri" pitchFamily="34" charset="-120"/>
               </a:rPr>
-              <a:t>Years of rising demand, world-class developments, and new communities.</a:t>
-            </a:r>
-            <a:endParaRPr lang="en-US" sz="1250" dirty="0"/>
+              <a:t>Decades of rising demand and landmark projects.</a:t>
+            </a:r>
+            <a:endParaRPr lang="en-US" sz="1150" dirty="0"/>
+          </a:p>
+        </p:txBody>
+      </p:sp>
+      <p:sp>
+        <p:nvSpPr>
+          <p:cNvPr id="28" name="Text 21"/>
+          <p:cNvSpPr/>
+          <p:nvPr/>
+        </p:nvSpPr>
+        <p:spPr>
+          <a:xfrm>
+            <a:off x="7485736" y="4818888"/>
+            <a:ext cx="3855568" cy="676656"/>
+          </a:xfrm>
+          <a:prstGeom prst="rect">
+            <a:avLst/>
+          </a:prstGeom>
+          <a:noFill/>
+          <a:ln/>
+        </p:spPr>
+        <p:txBody>
+          <a:bodyPr wrap="square" rtlCol="0" anchor="t"/>
+          <a:lstStyle/>
+          <a:p>
+            <a:pPr indent="0" marL="0">
+              <a:lnSpc>
+                <a:spcPct val="104000"/>
+              </a:lnSpc>
+              <a:buNone/>
+            </a:pPr>
+            <a:r>
+              <a:rPr lang="en-US" sz="1050" b="1" dirty="0">
+                <a:solidFill>
+                  <a:srgbClr val="C9A24B"/>
+                </a:solidFill>
+                <a:latin typeface="Calibri" pitchFamily="34" charset="0"/>
+                <a:ea typeface="Calibri" pitchFamily="34" charset="-122"/>
+                <a:cs typeface="Calibri" pitchFamily="34" charset="-120"/>
+              </a:rPr>
+              <a:t>→  </a:t>
+            </a:r>
+            <a:pPr indent="0" marL="0">
+              <a:lnSpc>
+                <a:spcPct val="104000"/>
+              </a:lnSpc>
+              <a:buNone/>
+            </a:pPr>
+            <a:r>
+              <a:rPr lang="en-US" sz="1050" i="1" dirty="0">
+                <a:solidFill>
+                  <a:srgbClr val="64748B"/>
+                </a:solidFill>
+                <a:latin typeface="Calibri" pitchFamily="34" charset="0"/>
+                <a:ea typeface="Calibri" pitchFamily="34" charset="-122"/>
+                <a:cs typeface="Calibri" pitchFamily="34" charset="-120"/>
+              </a:rPr>
+              <a:t>New districts keep rising — Marina, Downtown, Dubai Hills.</a:t>
+            </a:r>
+            <a:endParaRPr lang="en-US" sz="1050" dirty="0"/>
           </a:p>
         </p:txBody>
       </p:sp>
@@ -7480,12 +7708,12 @@
         </p:nvSpPr>
         <p:spPr>
           <a:xfrm>
-            <a:off x="640080" y="1874520"/>
-            <a:ext cx="5272888" cy="1554480"/>
+            <a:off x="640080" y="1783080"/>
+            <a:ext cx="5272888" cy="1828800"/>
           </a:xfrm>
           <a:prstGeom prst="roundRect">
             <a:avLst>
-              <a:gd name="adj" fmla="val 5882"/>
+              <a:gd name="adj" fmla="val 5000"/>
             </a:avLst>
           </a:prstGeom>
           <a:solidFill>
@@ -7509,8 +7737,8 @@
         </p:nvSpPr>
         <p:spPr>
           <a:xfrm>
-            <a:off x="914400" y="2240280"/>
-            <a:ext cx="822960" cy="822960"/>
+            <a:off x="914400" y="2093976"/>
+            <a:ext cx="749808" cy="749808"/>
           </a:xfrm>
           <a:prstGeom prst="ellipse">
             <a:avLst/>
@@ -7544,8 +7772,8 @@
         </p:blipFill>
         <p:spPr>
           <a:xfrm>
-            <a:off x="1136599" y="2462479"/>
-            <a:ext cx="378562" cy="378562"/>
+            <a:off x="1116848" y="2296424"/>
+            <a:ext cx="344912" cy="344912"/>
           </a:xfrm>
           <a:prstGeom prst="rect">
             <a:avLst/>
@@ -7560,8 +7788,8 @@
         </p:nvSpPr>
         <p:spPr>
           <a:xfrm>
-            <a:off x="1920240" y="2167128"/>
-            <a:ext cx="3764128" cy="457200"/>
+            <a:off x="1847088" y="2002536"/>
+            <a:ext cx="3855568" cy="384048"/>
           </a:xfrm>
           <a:prstGeom prst="rect">
             <a:avLst/>
@@ -7577,7 +7805,7 @@
               <a:buNone/>
             </a:pPr>
             <a:r>
-              <a:rPr lang="en-US" sz="1700" b="1" dirty="0">
+              <a:rPr lang="en-US" sz="1600" b="1" dirty="0">
                 <a:solidFill>
                   <a:srgbClr val="0F1F3D"/>
                 </a:solidFill>
@@ -7587,7 +7815,7 @@
               </a:rPr>
               <a:t>Billions every week</a:t>
             </a:r>
-            <a:endParaRPr lang="en-US" sz="1700" dirty="0"/>
+            <a:endParaRPr lang="en-US" sz="1600" dirty="0"/>
           </a:p>
         </p:txBody>
       </p:sp>
@@ -7599,8 +7827,8 @@
         </p:nvSpPr>
         <p:spPr>
           <a:xfrm>
-            <a:off x="1920240" y="2651760"/>
-            <a:ext cx="3764128" cy="685800"/>
+            <a:off x="1847088" y="2386584"/>
+            <a:ext cx="3855568" cy="365760"/>
           </a:xfrm>
           <a:prstGeom prst="rect">
             <a:avLst/>
@@ -7613,13 +7841,10 @@
           <a:lstStyle/>
           <a:p>
             <a:pPr indent="0" marL="0">
-              <a:lnSpc>
-                <a:spcPct val="105000"/>
-              </a:lnSpc>
-              <a:buNone/>
-            </a:pPr>
-            <a:r>
-              <a:rPr lang="en-US" sz="1250" dirty="0">
+              <a:buNone/>
+            </a:pPr>
+            <a:r>
+              <a:rPr lang="en-US" sz="1150" dirty="0">
                 <a:solidFill>
                   <a:srgbClr val="1E293B"/>
                 </a:solidFill>
@@ -7627,26 +7852,85 @@
                 <a:ea typeface="Calibri" pitchFamily="34" charset="-122"/>
                 <a:cs typeface="Calibri" pitchFamily="34" charset="-120"/>
               </a:rPr>
-              <a:t>Property worth billions of dirhams changes hands across Dubai — week after week.</a:t>
-            </a:r>
-            <a:endParaRPr lang="en-US" sz="1250" dirty="0"/>
-          </a:p>
-        </p:txBody>
-      </p:sp>
-      <p:sp>
-        <p:nvSpPr>
-          <p:cNvPr id="10" name="Shape 6"/>
-          <p:cNvSpPr/>
-          <p:nvPr/>
-        </p:nvSpPr>
-        <p:spPr>
-          <a:xfrm>
-            <a:off x="6278728" y="1874520"/>
-            <a:ext cx="5272888" cy="1554480"/>
+              <a:t>Dirhams in property change hands week after week.</a:t>
+            </a:r>
+            <a:endParaRPr lang="en-US" sz="1150" dirty="0"/>
+          </a:p>
+        </p:txBody>
+      </p:sp>
+      <p:sp>
+        <p:nvSpPr>
+          <p:cNvPr id="10" name="Text 6"/>
+          <p:cNvSpPr/>
+          <p:nvPr/>
+        </p:nvSpPr>
+        <p:spPr>
+          <a:xfrm>
+            <a:off x="1847088" y="2807208"/>
+            <a:ext cx="3855568" cy="676656"/>
+          </a:xfrm>
+          <a:prstGeom prst="rect">
+            <a:avLst/>
+          </a:prstGeom>
+          <a:noFill/>
+          <a:ln/>
+        </p:spPr>
+        <p:txBody>
+          <a:bodyPr wrap="square" rtlCol="0" anchor="t"/>
+          <a:lstStyle/>
+          <a:p>
+            <a:pPr indent="0" marL="0">
+              <a:lnSpc>
+                <a:spcPct val="104000"/>
+              </a:lnSpc>
+              <a:buNone/>
+            </a:pPr>
+            <a:r>
+              <a:rPr lang="en-US" sz="1050" b="1" dirty="0">
+                <a:solidFill>
+                  <a:srgbClr val="C9A24B"/>
+                </a:solidFill>
+                <a:latin typeface="Calibri" pitchFamily="34" charset="0"/>
+                <a:ea typeface="Calibri" pitchFamily="34" charset="-122"/>
+                <a:cs typeface="Calibri" pitchFamily="34" charset="-120"/>
+              </a:rPr>
+              <a:t>→  </a:t>
+            </a:r>
+            <a:pPr indent="0" marL="0">
+              <a:lnSpc>
+                <a:spcPct val="104000"/>
+              </a:lnSpc>
+              <a:buNone/>
+            </a:pPr>
+            <a:r>
+              <a:rPr lang="en-US" sz="1050" i="1" dirty="0">
+                <a:solidFill>
+                  <a:srgbClr val="64748B"/>
+                </a:solidFill>
+                <a:latin typeface="Calibri" pitchFamily="34" charset="0"/>
+                <a:ea typeface="Calibri" pitchFamily="34" charset="-122"/>
+                <a:cs typeface="Calibri" pitchFamily="34" charset="-120"/>
+              </a:rPr>
+              <a:t>1,000+ homes find new owners every single week.</a:t>
+            </a:r>
+            <a:endParaRPr lang="en-US" sz="1050" dirty="0"/>
+          </a:p>
+        </p:txBody>
+      </p:sp>
+      <p:sp>
+        <p:nvSpPr>
+          <p:cNvPr id="11" name="Shape 7"/>
+          <p:cNvSpPr/>
+          <p:nvPr/>
+        </p:nvSpPr>
+        <p:spPr>
+          <a:xfrm>
+            <a:off x="6278728" y="1783080"/>
+            <a:ext cx="5272888" cy="1828800"/>
           </a:xfrm>
           <a:prstGeom prst="roundRect">
             <a:avLst>
-              <a:gd name="adj" fmla="val 5882"/>
+              <a:gd name="adj" fmla="val 5000"/>
             </a:avLst>
           </a:prstGeom>
           <a:solidFill>
@@ -7664,14 +7948,14 @@
       </p:sp>
       <p:sp>
         <p:nvSpPr>
-          <p:cNvPr id="11" name="Shape 7"/>
-          <p:cNvSpPr/>
-          <p:nvPr/>
-        </p:nvSpPr>
-        <p:spPr>
-          <a:xfrm>
-            <a:off x="6553048" y="2240280"/>
-            <a:ext cx="822960" cy="822960"/>
+          <p:cNvPr id="12" name="Shape 8"/>
+          <p:cNvSpPr/>
+          <p:nvPr/>
+        </p:nvSpPr>
+        <p:spPr>
+          <a:xfrm>
+            <a:off x="6553048" y="2093976"/>
+            <a:ext cx="749808" cy="749808"/>
           </a:xfrm>
           <a:prstGeom prst="ellipse">
             <a:avLst/>
@@ -7691,7 +7975,7 @@
       </p:sp>
       <p:pic>
         <p:nvPicPr>
-          <p:cNvPr id="12" name="Image 2" descr="preencoded.png">    </p:cNvPr>
+          <p:cNvPr id="13" name="Image 2" descr="preencoded.png">    </p:cNvPr>
           <p:cNvPicPr>
             <a:picLocks noChangeAspect="1"/>
           </p:cNvPicPr>
@@ -7705,8 +7989,8 @@
         </p:blipFill>
         <p:spPr>
           <a:xfrm>
-            <a:off x="6775247" y="2462479"/>
-            <a:ext cx="378562" cy="378562"/>
+            <a:off x="6755496" y="2296424"/>
+            <a:ext cx="344912" cy="344912"/>
           </a:xfrm>
           <a:prstGeom prst="rect">
             <a:avLst/>
@@ -7715,14 +7999,14 @@
       </p:pic>
       <p:sp>
         <p:nvSpPr>
-          <p:cNvPr id="13" name="Text 8"/>
-          <p:cNvSpPr/>
-          <p:nvPr/>
-        </p:nvSpPr>
-        <p:spPr>
-          <a:xfrm>
-            <a:off x="7558888" y="2167128"/>
-            <a:ext cx="3764128" cy="457200"/>
+          <p:cNvPr id="14" name="Text 9"/>
+          <p:cNvSpPr/>
+          <p:nvPr/>
+        </p:nvSpPr>
+        <p:spPr>
+          <a:xfrm>
+            <a:off x="7485736" y="2002536"/>
+            <a:ext cx="3855568" cy="384048"/>
           </a:xfrm>
           <a:prstGeom prst="rect">
             <a:avLst/>
@@ -7738,7 +8022,7 @@
               <a:buNone/>
             </a:pPr>
             <a:r>
-              <a:rPr lang="en-US" sz="1700" b="1" dirty="0">
+              <a:rPr lang="en-US" sz="1600" b="1" dirty="0">
                 <a:solidFill>
                   <a:srgbClr val="0F1F3D"/>
                 </a:solidFill>
@@ -7748,20 +8032,20 @@
               </a:rPr>
               <a:t>A world of buyers</a:t>
             </a:r>
-            <a:endParaRPr lang="en-US" sz="1700" dirty="0"/>
-          </a:p>
-        </p:txBody>
-      </p:sp>
-      <p:sp>
-        <p:nvSpPr>
-          <p:cNvPr id="14" name="Text 9"/>
-          <p:cNvSpPr/>
-          <p:nvPr/>
-        </p:nvSpPr>
-        <p:spPr>
-          <a:xfrm>
-            <a:off x="7558888" y="2651760"/>
-            <a:ext cx="3764128" cy="685800"/>
+            <a:endParaRPr lang="en-US" sz="1600" dirty="0"/>
+          </a:p>
+        </p:txBody>
+      </p:sp>
+      <p:sp>
+        <p:nvSpPr>
+          <p:cNvPr id="15" name="Text 10"/>
+          <p:cNvSpPr/>
+          <p:nvPr/>
+        </p:nvSpPr>
+        <p:spPr>
+          <a:xfrm>
+            <a:off x="7485736" y="2386584"/>
+            <a:ext cx="3855568" cy="365760"/>
           </a:xfrm>
           <a:prstGeom prst="rect">
             <a:avLst/>
@@ -7774,13 +8058,10 @@
           <a:lstStyle/>
           <a:p>
             <a:pPr indent="0" marL="0">
-              <a:lnSpc>
-                <a:spcPct val="105000"/>
-              </a:lnSpc>
-              <a:buNone/>
-            </a:pPr>
-            <a:r>
-              <a:rPr lang="en-US" sz="1250" dirty="0">
+              <a:buNone/>
+            </a:pPr>
+            <a:r>
+              <a:rPr lang="en-US" sz="1150" dirty="0">
                 <a:solidFill>
                   <a:srgbClr val="1E293B"/>
                 </a:solidFill>
@@ -7788,26 +8069,85 @@
                 <a:ea typeface="Calibri" pitchFamily="34" charset="-122"/>
                 <a:cs typeface="Calibri" pitchFamily="34" charset="-120"/>
               </a:rPr>
-              <a:t>People from 200+ nationalities live here. Your clients can come from anywhere.</a:t>
-            </a:r>
-            <a:endParaRPr lang="en-US" sz="1250" dirty="0"/>
-          </a:p>
-        </p:txBody>
-      </p:sp>
-      <p:sp>
-        <p:nvSpPr>
-          <p:cNvPr id="15" name="Shape 10"/>
-          <p:cNvSpPr/>
-          <p:nvPr/>
-        </p:nvSpPr>
-        <p:spPr>
-          <a:xfrm>
-            <a:off x="640080" y="3657600"/>
-            <a:ext cx="5272888" cy="1554480"/>
+              <a:t>Buyers come from all over the planet.</a:t>
+            </a:r>
+            <a:endParaRPr lang="en-US" sz="1150" dirty="0"/>
+          </a:p>
+        </p:txBody>
+      </p:sp>
+      <p:sp>
+        <p:nvSpPr>
+          <p:cNvPr id="16" name="Text 11"/>
+          <p:cNvSpPr/>
+          <p:nvPr/>
+        </p:nvSpPr>
+        <p:spPr>
+          <a:xfrm>
+            <a:off x="7485736" y="2807208"/>
+            <a:ext cx="3855568" cy="676656"/>
+          </a:xfrm>
+          <a:prstGeom prst="rect">
+            <a:avLst/>
+          </a:prstGeom>
+          <a:noFill/>
+          <a:ln/>
+        </p:spPr>
+        <p:txBody>
+          <a:bodyPr wrap="square" rtlCol="0" anchor="t"/>
+          <a:lstStyle/>
+          <a:p>
+            <a:pPr indent="0" marL="0">
+              <a:lnSpc>
+                <a:spcPct val="104000"/>
+              </a:lnSpc>
+              <a:buNone/>
+            </a:pPr>
+            <a:r>
+              <a:rPr lang="en-US" sz="1050" b="1" dirty="0">
+                <a:solidFill>
+                  <a:srgbClr val="C9A24B"/>
+                </a:solidFill>
+                <a:latin typeface="Calibri" pitchFamily="34" charset="0"/>
+                <a:ea typeface="Calibri" pitchFamily="34" charset="-122"/>
+                <a:cs typeface="Calibri" pitchFamily="34" charset="-120"/>
+              </a:rPr>
+              <a:t>→  </a:t>
+            </a:r>
+            <a:pPr indent="0" marL="0">
+              <a:lnSpc>
+                <a:spcPct val="104000"/>
+              </a:lnSpc>
+              <a:buNone/>
+            </a:pPr>
+            <a:r>
+              <a:rPr lang="en-US" sz="1050" i="1" dirty="0">
+                <a:solidFill>
+                  <a:srgbClr val="64748B"/>
+                </a:solidFill>
+                <a:latin typeface="Calibri" pitchFamily="34" charset="0"/>
+                <a:ea typeface="Calibri" pitchFamily="34" charset="-122"/>
+                <a:cs typeface="Calibri" pitchFamily="34" charset="-120"/>
+              </a:rPr>
+              <a:t>Your next client could be from London, Mumbai or Moscow.</a:t>
+            </a:r>
+            <a:endParaRPr lang="en-US" sz="1050" dirty="0"/>
+          </a:p>
+        </p:txBody>
+      </p:sp>
+      <p:sp>
+        <p:nvSpPr>
+          <p:cNvPr id="17" name="Shape 12"/>
+          <p:cNvSpPr/>
+          <p:nvPr/>
+        </p:nvSpPr>
+        <p:spPr>
+          <a:xfrm>
+            <a:off x="640080" y="3794760"/>
+            <a:ext cx="5272888" cy="1828800"/>
           </a:xfrm>
           <a:prstGeom prst="roundRect">
             <a:avLst>
-              <a:gd name="adj" fmla="val 5882"/>
+              <a:gd name="adj" fmla="val 5000"/>
             </a:avLst>
           </a:prstGeom>
           <a:solidFill>
@@ -7825,14 +8165,14 @@
       </p:sp>
       <p:sp>
         <p:nvSpPr>
-          <p:cNvPr id="16" name="Shape 11"/>
-          <p:cNvSpPr/>
-          <p:nvPr/>
-        </p:nvSpPr>
-        <p:spPr>
-          <a:xfrm>
-            <a:off x="914400" y="4023360"/>
-            <a:ext cx="822960" cy="822960"/>
+          <p:cNvPr id="18" name="Shape 13"/>
+          <p:cNvSpPr/>
+          <p:nvPr/>
+        </p:nvSpPr>
+        <p:spPr>
+          <a:xfrm>
+            <a:off x="914400" y="4105656"/>
+            <a:ext cx="749808" cy="749808"/>
           </a:xfrm>
           <a:prstGeom prst="ellipse">
             <a:avLst/>
@@ -7852,7 +8192,7 @@
       </p:sp>
       <p:pic>
         <p:nvPicPr>
-          <p:cNvPr id="17" name="Image 3" descr="preencoded.png">    </p:cNvPr>
+          <p:cNvPr id="19" name="Image 3" descr="preencoded.png">    </p:cNvPr>
           <p:cNvPicPr>
             <a:picLocks noChangeAspect="1"/>
           </p:cNvPicPr>
@@ -7866,8 +8206,8 @@
         </p:blipFill>
         <p:spPr>
           <a:xfrm>
-            <a:off x="1136599" y="4245559"/>
-            <a:ext cx="378562" cy="378562"/>
+            <a:off x="1116848" y="4308104"/>
+            <a:ext cx="344912" cy="344912"/>
           </a:xfrm>
           <a:prstGeom prst="rect">
             <a:avLst/>
@@ -7876,14 +8216,14 @@
       </p:pic>
       <p:sp>
         <p:nvSpPr>
-          <p:cNvPr id="18" name="Text 12"/>
-          <p:cNvSpPr/>
-          <p:nvPr/>
-        </p:nvSpPr>
-        <p:spPr>
-          <a:xfrm>
-            <a:off x="1920240" y="3950208"/>
-            <a:ext cx="3764128" cy="457200"/>
+          <p:cNvPr id="20" name="Text 14"/>
+          <p:cNvSpPr/>
+          <p:nvPr/>
+        </p:nvSpPr>
+        <p:spPr>
+          <a:xfrm>
+            <a:off x="1847088" y="4014216"/>
+            <a:ext cx="3855568" cy="384048"/>
           </a:xfrm>
           <a:prstGeom prst="rect">
             <a:avLst/>
@@ -7899,7 +8239,7 @@
               <a:buNone/>
             </a:pPr>
             <a:r>
-              <a:rPr lang="en-US" sz="1700" b="1" dirty="0">
+              <a:rPr lang="en-US" sz="1600" b="1" dirty="0">
                 <a:solidFill>
                   <a:srgbClr val="0F1F3D"/>
                 </a:solidFill>
@@ -7909,20 +8249,20 @@
               </a:rPr>
               <a:t>Always building</a:t>
             </a:r>
-            <a:endParaRPr lang="en-US" sz="1700" dirty="0"/>
-          </a:p>
-        </p:txBody>
-      </p:sp>
-      <p:sp>
-        <p:nvSpPr>
-          <p:cNvPr id="19" name="Text 13"/>
-          <p:cNvSpPr/>
-          <p:nvPr/>
-        </p:nvSpPr>
-        <p:spPr>
-          <a:xfrm>
-            <a:off x="1920240" y="4434840"/>
-            <a:ext cx="3764128" cy="685800"/>
+            <a:endParaRPr lang="en-US" sz="1600" dirty="0"/>
+          </a:p>
+        </p:txBody>
+      </p:sp>
+      <p:sp>
+        <p:nvSpPr>
+          <p:cNvPr id="21" name="Text 15"/>
+          <p:cNvSpPr/>
+          <p:nvPr/>
+        </p:nvSpPr>
+        <p:spPr>
+          <a:xfrm>
+            <a:off x="1847088" y="4398264"/>
+            <a:ext cx="3855568" cy="365760"/>
           </a:xfrm>
           <a:prstGeom prst="rect">
             <a:avLst/>
@@ -7935,13 +8275,10 @@
           <a:lstStyle/>
           <a:p>
             <a:pPr indent="0" marL="0">
-              <a:lnSpc>
-                <a:spcPct val="105000"/>
-              </a:lnSpc>
-              <a:buNone/>
-            </a:pPr>
-            <a:r>
-              <a:rPr lang="en-US" sz="1250" dirty="0">
+              <a:buNone/>
+            </a:pPr>
+            <a:r>
+              <a:rPr lang="en-US" sz="1150" dirty="0">
                 <a:solidFill>
                   <a:srgbClr val="1E293B"/>
                 </a:solidFill>
@@ -7949,26 +8286,85 @@
                 <a:ea typeface="Calibri" pitchFamily="34" charset="-122"/>
                 <a:cs typeface="Calibri" pitchFamily="34" charset="-120"/>
               </a:rPr>
-              <a:t>New communities and landmark towers launch constantly — fresh homes to sell.</a:t>
-            </a:r>
-            <a:endParaRPr lang="en-US" sz="1250" dirty="0"/>
-          </a:p>
-        </p:txBody>
-      </p:sp>
-      <p:sp>
-        <p:nvSpPr>
-          <p:cNvPr id="20" name="Shape 14"/>
-          <p:cNvSpPr/>
-          <p:nvPr/>
-        </p:nvSpPr>
-        <p:spPr>
-          <a:xfrm>
-            <a:off x="6278728" y="3657600"/>
-            <a:ext cx="5272888" cy="1554480"/>
+              <a:t>New communities and towers launch constantly.</a:t>
+            </a:r>
+            <a:endParaRPr lang="en-US" sz="1150" dirty="0"/>
+          </a:p>
+        </p:txBody>
+      </p:sp>
+      <p:sp>
+        <p:nvSpPr>
+          <p:cNvPr id="22" name="Text 16"/>
+          <p:cNvSpPr/>
+          <p:nvPr/>
+        </p:nvSpPr>
+        <p:spPr>
+          <a:xfrm>
+            <a:off x="1847088" y="4818888"/>
+            <a:ext cx="3855568" cy="676656"/>
+          </a:xfrm>
+          <a:prstGeom prst="rect">
+            <a:avLst/>
+          </a:prstGeom>
+          <a:noFill/>
+          <a:ln/>
+        </p:spPr>
+        <p:txBody>
+          <a:bodyPr wrap="square" rtlCol="0" anchor="t"/>
+          <a:lstStyle/>
+          <a:p>
+            <a:pPr indent="0" marL="0">
+              <a:lnSpc>
+                <a:spcPct val="104000"/>
+              </a:lnSpc>
+              <a:buNone/>
+            </a:pPr>
+            <a:r>
+              <a:rPr lang="en-US" sz="1050" b="1" dirty="0">
+                <a:solidFill>
+                  <a:srgbClr val="C9A24B"/>
+                </a:solidFill>
+                <a:latin typeface="Calibri" pitchFamily="34" charset="0"/>
+                <a:ea typeface="Calibri" pitchFamily="34" charset="-122"/>
+                <a:cs typeface="Calibri" pitchFamily="34" charset="-120"/>
+              </a:rPr>
+              <a:t>→  </a:t>
+            </a:r>
+            <a:pPr indent="0" marL="0">
+              <a:lnSpc>
+                <a:spcPct val="104000"/>
+              </a:lnSpc>
+              <a:buNone/>
+            </a:pPr>
+            <a:r>
+              <a:rPr lang="en-US" sz="1050" i="1" dirty="0">
+                <a:solidFill>
+                  <a:srgbClr val="64748B"/>
+                </a:solidFill>
+                <a:latin typeface="Calibri" pitchFamily="34" charset="0"/>
+                <a:ea typeface="Calibri" pitchFamily="34" charset="-122"/>
+                <a:cs typeface="Calibri" pitchFamily="34" charset="-120"/>
+              </a:rPr>
+              <a:t>Fresh launches from Emaar, DAMAC, Sobha &amp; Nakheel.</a:t>
+            </a:r>
+            <a:endParaRPr lang="en-US" sz="1050" dirty="0"/>
+          </a:p>
+        </p:txBody>
+      </p:sp>
+      <p:sp>
+        <p:nvSpPr>
+          <p:cNvPr id="23" name="Shape 17"/>
+          <p:cNvSpPr/>
+          <p:nvPr/>
+        </p:nvSpPr>
+        <p:spPr>
+          <a:xfrm>
+            <a:off x="6278728" y="3794760"/>
+            <a:ext cx="5272888" cy="1828800"/>
           </a:xfrm>
           <a:prstGeom prst="roundRect">
             <a:avLst>
-              <a:gd name="adj" fmla="val 5882"/>
+              <a:gd name="adj" fmla="val 5000"/>
             </a:avLst>
           </a:prstGeom>
           <a:solidFill>
@@ -7986,14 +8382,14 @@
       </p:sp>
       <p:sp>
         <p:nvSpPr>
-          <p:cNvPr id="21" name="Shape 15"/>
-          <p:cNvSpPr/>
-          <p:nvPr/>
-        </p:nvSpPr>
-        <p:spPr>
-          <a:xfrm>
-            <a:off x="6553048" y="4023360"/>
-            <a:ext cx="822960" cy="822960"/>
+          <p:cNvPr id="24" name="Shape 18"/>
+          <p:cNvSpPr/>
+          <p:nvPr/>
+        </p:nvSpPr>
+        <p:spPr>
+          <a:xfrm>
+            <a:off x="6553048" y="4105656"/>
+            <a:ext cx="749808" cy="749808"/>
           </a:xfrm>
           <a:prstGeom prst="ellipse">
             <a:avLst/>
@@ -8013,7 +8409,7 @@
       </p:sp>
       <p:pic>
         <p:nvPicPr>
-          <p:cNvPr id="22" name="Image 4" descr="preencoded.png">    </p:cNvPr>
+          <p:cNvPr id="25" name="Image 4" descr="preencoded.png">    </p:cNvPr>
           <p:cNvPicPr>
             <a:picLocks noChangeAspect="1"/>
           </p:cNvPicPr>
@@ -8027,8 +8423,8 @@
         </p:blipFill>
         <p:spPr>
           <a:xfrm>
-            <a:off x="6775247" y="4245559"/>
-            <a:ext cx="378562" cy="378562"/>
+            <a:off x="6755496" y="4308104"/>
+            <a:ext cx="344912" cy="344912"/>
           </a:xfrm>
           <a:prstGeom prst="rect">
             <a:avLst/>
@@ -8037,14 +8433,14 @@
       </p:pic>
       <p:sp>
         <p:nvSpPr>
-          <p:cNvPr id="23" name="Text 16"/>
-          <p:cNvSpPr/>
-          <p:nvPr/>
-        </p:nvSpPr>
-        <p:spPr>
-          <a:xfrm>
-            <a:off x="7558888" y="3950208"/>
-            <a:ext cx="3764128" cy="457200"/>
+          <p:cNvPr id="26" name="Text 19"/>
+          <p:cNvSpPr/>
+          <p:nvPr/>
+        </p:nvSpPr>
+        <p:spPr>
+          <a:xfrm>
+            <a:off x="7485736" y="4014216"/>
+            <a:ext cx="3855568" cy="384048"/>
           </a:xfrm>
           <a:prstGeom prst="rect">
             <a:avLst/>
@@ -8060,7 +8456,7 @@
               <a:buNone/>
             </a:pPr>
             <a:r>
-              <a:rPr lang="en-US" sz="1700" b="1" dirty="0">
+              <a:rPr lang="en-US" sz="1600" b="1" dirty="0">
                 <a:solidFill>
                   <a:srgbClr val="0F1F3D"/>
                 </a:solidFill>
@@ -8068,22 +8464,22 @@
                 <a:ea typeface="Cambria" pitchFamily="34" charset="-122"/>
                 <a:cs typeface="Cambria" pitchFamily="34" charset="-120"/>
               </a:rPr>
-              <a:t>Long-term demand</a:t>
-            </a:r>
-            <a:endParaRPr lang="en-US" sz="1700" dirty="0"/>
-          </a:p>
-        </p:txBody>
-      </p:sp>
-      <p:sp>
-        <p:nvSpPr>
-          <p:cNvPr id="24" name="Text 17"/>
-          <p:cNvSpPr/>
-          <p:nvPr/>
-        </p:nvSpPr>
-        <p:spPr>
-          <a:xfrm>
-            <a:off x="7558888" y="4434840"/>
-            <a:ext cx="3764128" cy="685800"/>
+              <a:t>A growing city</a:t>
+            </a:r>
+            <a:endParaRPr lang="en-US" sz="1600" dirty="0"/>
+          </a:p>
+        </p:txBody>
+      </p:sp>
+      <p:sp>
+        <p:nvSpPr>
+          <p:cNvPr id="27" name="Text 20"/>
+          <p:cNvSpPr/>
+          <p:nvPr/>
+        </p:nvSpPr>
+        <p:spPr>
+          <a:xfrm>
+            <a:off x="7485736" y="4398264"/>
+            <a:ext cx="3855568" cy="365760"/>
           </a:xfrm>
           <a:prstGeom prst="rect">
             <a:avLst/>
@@ -8096,13 +8492,10 @@
           <a:lstStyle/>
           <a:p>
             <a:pPr indent="0" marL="0">
-              <a:lnSpc>
-                <a:spcPct val="105000"/>
-              </a:lnSpc>
-              <a:buNone/>
-            </a:pPr>
-            <a:r>
-              <a:rPr lang="en-US" sz="1250" dirty="0">
+              <a:buNone/>
+            </a:pPr>
+            <a:r>
+              <a:rPr lang="en-US" sz="1150" dirty="0">
                 <a:solidFill>
                   <a:srgbClr val="1E293B"/>
                 </a:solidFill>
@@ -8110,9 +8503,68 @@
                 <a:ea typeface="Calibri" pitchFamily="34" charset="-122"/>
                 <a:cs typeface="Calibri" pitchFamily="34" charset="-120"/>
               </a:rPr>
-              <a:t>Population and investment keep climbing, year after year.</a:t>
-            </a:r>
-            <a:endParaRPr lang="en-US" sz="1250" dirty="0"/>
+              <a:t>More people arrive every year — future tenants &amp; buyers.</a:t>
+            </a:r>
+            <a:endParaRPr lang="en-US" sz="1150" dirty="0"/>
+          </a:p>
+        </p:txBody>
+      </p:sp>
+      <p:sp>
+        <p:nvSpPr>
+          <p:cNvPr id="28" name="Text 21"/>
+          <p:cNvSpPr/>
+          <p:nvPr/>
+        </p:nvSpPr>
+        <p:spPr>
+          <a:xfrm>
+            <a:off x="7485736" y="4818888"/>
+            <a:ext cx="3855568" cy="676656"/>
+          </a:xfrm>
+          <a:prstGeom prst="rect">
+            <a:avLst/>
+          </a:prstGeom>
+          <a:noFill/>
+          <a:ln/>
+        </p:spPr>
+        <p:txBody>
+          <a:bodyPr wrap="square" rtlCol="0" anchor="t"/>
+          <a:lstStyle/>
+          <a:p>
+            <a:pPr indent="0" marL="0">
+              <a:lnSpc>
+                <a:spcPct val="104000"/>
+              </a:lnSpc>
+              <a:buNone/>
+            </a:pPr>
+            <a:r>
+              <a:rPr lang="en-US" sz="1050" b="1" dirty="0">
+                <a:solidFill>
+                  <a:srgbClr val="C9A24B"/>
+                </a:solidFill>
+                <a:latin typeface="Calibri" pitchFamily="34" charset="0"/>
+                <a:ea typeface="Calibri" pitchFamily="34" charset="-122"/>
+                <a:cs typeface="Calibri" pitchFamily="34" charset="-120"/>
+              </a:rPr>
+              <a:t>→  </a:t>
+            </a:r>
+            <a:pPr indent="0" marL="0">
+              <a:lnSpc>
+                <a:spcPct val="104000"/>
+              </a:lnSpc>
+              <a:buNone/>
+            </a:pPr>
+            <a:r>
+              <a:rPr lang="en-US" sz="1050" i="1" dirty="0">
+                <a:solidFill>
+                  <a:srgbClr val="64748B"/>
+                </a:solidFill>
+                <a:latin typeface="Calibri" pitchFamily="34" charset="0"/>
+                <a:ea typeface="Calibri" pitchFamily="34" charset="-122"/>
+                <a:cs typeface="Calibri" pitchFamily="34" charset="-120"/>
+              </a:rPr>
+              <a:t>Past 4 million residents · ~200,000 added a year · 5.8M target by 2040.</a:t>
+            </a:r>
+            <a:endParaRPr lang="en-US" sz="1050" dirty="0"/>
           </a:p>
         </p:txBody>
       </p:sp>

</xml_diff>